<commit_message>
update candidate voice search
</commit_message>
<xml_diff>
--- a/Project/Review_Presentation.pptx
+++ b/Project/Review_Presentation.pptx
@@ -3178,7 +3178,7 @@
           <a:p>
             <a:fld id="{5BCAD085-E8A6-8845-BD4E-CB4CCA059FC4}" type="datetimeFigureOut">
               <a:rPr lang="en-US" smtClean="0"/>
-              <a:t>2/27/2026</a:t>
+              <a:t>3/1/2026</a:t>
             </a:fld>
             <a:endParaRPr lang="en-US"/>
           </a:p>
@@ -3453,7 +3453,7 @@
           <a:p>
             <a:fld id="{5BCAD085-E8A6-8845-BD4E-CB4CCA059FC4}" type="datetimeFigureOut">
               <a:rPr lang="en-US" smtClean="0"/>
-              <a:t>2/27/2026</a:t>
+              <a:t>3/1/2026</a:t>
             </a:fld>
             <a:endParaRPr lang="en-US"/>
           </a:p>
@@ -3647,7 +3647,7 @@
           <a:p>
             <a:fld id="{5BCAD085-E8A6-8845-BD4E-CB4CCA059FC4}" type="datetimeFigureOut">
               <a:rPr lang="en-US" smtClean="0"/>
-              <a:t>2/27/2026</a:t>
+              <a:t>3/1/2026</a:t>
             </a:fld>
             <a:endParaRPr lang="en-US"/>
           </a:p>
@@ -3920,7 +3920,7 @@
           <a:p>
             <a:fld id="{5BCAD085-E8A6-8845-BD4E-CB4CCA059FC4}" type="datetimeFigureOut">
               <a:rPr lang="en-US" smtClean="0"/>
-              <a:t>2/27/2026</a:t>
+              <a:t>3/1/2026</a:t>
             </a:fld>
             <a:endParaRPr lang="en-US"/>
           </a:p>
@@ -4261,7 +4261,7 @@
           <a:p>
             <a:fld id="{5BCAD085-E8A6-8845-BD4E-CB4CCA059FC4}" type="datetimeFigureOut">
               <a:rPr lang="en-US" smtClean="0"/>
-              <a:t>2/27/2026</a:t>
+              <a:t>3/1/2026</a:t>
             </a:fld>
             <a:endParaRPr lang="en-US"/>
           </a:p>
@@ -4884,7 +4884,7 @@
           <a:p>
             <a:fld id="{5BCAD085-E8A6-8845-BD4E-CB4CCA059FC4}" type="datetimeFigureOut">
               <a:rPr lang="en-US" smtClean="0"/>
-              <a:t>2/27/2026</a:t>
+              <a:t>3/1/2026</a:t>
             </a:fld>
             <a:endParaRPr lang="en-US"/>
           </a:p>
@@ -5744,7 +5744,7 @@
           <a:p>
             <a:fld id="{5BCAD085-E8A6-8845-BD4E-CB4CCA059FC4}" type="datetimeFigureOut">
               <a:rPr lang="en-US" smtClean="0"/>
-              <a:t>2/27/2026</a:t>
+              <a:t>3/1/2026</a:t>
             </a:fld>
             <a:endParaRPr lang="en-US"/>
           </a:p>
@@ -5914,7 +5914,7 @@
           <a:p>
             <a:fld id="{5BCAD085-E8A6-8845-BD4E-CB4CCA059FC4}" type="datetimeFigureOut">
               <a:rPr lang="en-US" smtClean="0"/>
-              <a:t>2/27/2026</a:t>
+              <a:t>3/1/2026</a:t>
             </a:fld>
             <a:endParaRPr lang="en-US"/>
           </a:p>
@@ -6094,7 +6094,7 @@
           <a:p>
             <a:fld id="{5BCAD085-E8A6-8845-BD4E-CB4CCA059FC4}" type="datetimeFigureOut">
               <a:rPr lang="en-US" smtClean="0"/>
-              <a:t>2/27/2026</a:t>
+              <a:t>3/1/2026</a:t>
             </a:fld>
             <a:endParaRPr lang="en-US"/>
           </a:p>
@@ -6264,7 +6264,7 @@
           <a:p>
             <a:fld id="{5BCAD085-E8A6-8845-BD4E-CB4CCA059FC4}" type="datetimeFigureOut">
               <a:rPr lang="en-US" smtClean="0"/>
-              <a:t>2/27/2026</a:t>
+              <a:t>3/1/2026</a:t>
             </a:fld>
             <a:endParaRPr lang="en-US"/>
           </a:p>
@@ -6511,7 +6511,7 @@
           <a:p>
             <a:fld id="{5BCAD085-E8A6-8845-BD4E-CB4CCA059FC4}" type="datetimeFigureOut">
               <a:rPr lang="en-US" smtClean="0"/>
-              <a:t>2/27/2026</a:t>
+              <a:t>3/1/2026</a:t>
             </a:fld>
             <a:endParaRPr lang="en-US"/>
           </a:p>
@@ -6803,7 +6803,7 @@
           <a:p>
             <a:fld id="{5BCAD085-E8A6-8845-BD4E-CB4CCA059FC4}" type="datetimeFigureOut">
               <a:rPr lang="en-US" smtClean="0"/>
-              <a:t>2/27/2026</a:t>
+              <a:t>3/1/2026</a:t>
             </a:fld>
             <a:endParaRPr lang="en-US"/>
           </a:p>
@@ -7247,7 +7247,7 @@
           <a:p>
             <a:fld id="{5BCAD085-E8A6-8845-BD4E-CB4CCA059FC4}" type="datetimeFigureOut">
               <a:rPr lang="en-US" smtClean="0"/>
-              <a:t>2/27/2026</a:t>
+              <a:t>3/1/2026</a:t>
             </a:fld>
             <a:endParaRPr lang="en-US"/>
           </a:p>
@@ -7365,7 +7365,7 @@
           <a:p>
             <a:fld id="{5BCAD085-E8A6-8845-BD4E-CB4CCA059FC4}" type="datetimeFigureOut">
               <a:rPr lang="en-US" smtClean="0"/>
-              <a:t>2/27/2026</a:t>
+              <a:t>3/1/2026</a:t>
             </a:fld>
             <a:endParaRPr lang="en-US"/>
           </a:p>
@@ -7460,7 +7460,7 @@
           <a:p>
             <a:fld id="{5BCAD085-E8A6-8845-BD4E-CB4CCA059FC4}" type="datetimeFigureOut">
               <a:rPr lang="en-US" smtClean="0"/>
-              <a:t>2/27/2026</a:t>
+              <a:t>3/1/2026</a:t>
             </a:fld>
             <a:endParaRPr lang="en-US"/>
           </a:p>
@@ -7739,7 +7739,7 @@
           <a:p>
             <a:fld id="{5BCAD085-E8A6-8845-BD4E-CB4CCA059FC4}" type="datetimeFigureOut">
               <a:rPr lang="en-US" smtClean="0"/>
-              <a:t>2/27/2026</a:t>
+              <a:t>3/1/2026</a:t>
             </a:fld>
             <a:endParaRPr lang="en-US"/>
           </a:p>
@@ -8014,7 +8014,7 @@
           <a:p>
             <a:fld id="{5BCAD085-E8A6-8845-BD4E-CB4CCA059FC4}" type="datetimeFigureOut">
               <a:rPr lang="en-US" smtClean="0"/>
-              <a:t>2/27/2026</a:t>
+              <a:t>3/1/2026</a:t>
             </a:fld>
             <a:endParaRPr lang="en-US"/>
           </a:p>
@@ -8621,7 +8621,7 @@
           <a:p>
             <a:fld id="{5BCAD085-E8A6-8845-BD4E-CB4CCA059FC4}" type="datetimeFigureOut">
               <a:rPr lang="en-US" smtClean="0"/>
-              <a:t>2/27/2026</a:t>
+              <a:t>3/1/2026</a:t>
             </a:fld>
             <a:endParaRPr lang="en-US"/>
           </a:p>
@@ -9279,13 +9279,6 @@
             <a:br>
               <a:rPr lang="en-US" sz="3300" dirty="0"/>
             </a:br>
-            <a:r>
-              <a:rPr lang="en-US" sz="3300" i="1" dirty="0"/>
-              <a:t>A self-learning, AI-powered hiring system</a:t>
-            </a:r>
-            <a:br>
-              <a:rPr lang="en-US" sz="6600" dirty="0"/>
-            </a:br>
             <a:endParaRPr lang="en-US" sz="6700" b="1" dirty="0">
               <a:solidFill>
                 <a:schemeClr val="tx1"/>
@@ -9760,6 +9753,30 @@
           </a:bodyPr>
           <a:lstStyle/>
           <a:p>
+            <a:pPr marL="0" indent="0">
+              <a:buNone/>
+            </a:pPr>
+            <a:r>
+              <a:rPr lang="en-US" dirty="0"/>
+              <a:t>During my internship, I worked on a recruitment support website.</a:t>
+            </a:r>
+          </a:p>
+          <a:p>
+            <a:pPr marL="0" indent="0">
+              <a:buNone/>
+            </a:pPr>
+            <a:r>
+              <a:rPr lang="en-US" dirty="0"/>
+              <a:t>The goal was to:</a:t>
+            </a:r>
+          </a:p>
+          <a:p>
+            <a:pPr marL="0" indent="0">
+              <a:buNone/>
+            </a:pPr>
+            <a:endParaRPr lang="en-US" dirty="0"/>
+          </a:p>
+          <a:p>
             <a:pPr marL="0" lvl="0" indent="0" defTabSz="914400" eaLnBrk="0" fontAlgn="base" hangingPunct="0">
               <a:lnSpc>
                 <a:spcPct val="90000"/>
@@ -9777,7 +9794,7 @@
             </a:pPr>
             <a:r>
               <a:rPr lang="en-US" dirty="0"/>
-              <a:t> Goes beyond keyword search</a:t>
+              <a:t> Help recruiters search candidates</a:t>
             </a:r>
           </a:p>
           <a:p>
@@ -9806,11 +9823,11 @@
             </a:r>
             <a:r>
               <a:rPr lang="en-US" dirty="0"/>
-              <a:t>Understands meaning (semantic matching)</a:t>
+              <a:t>Make filtering easier</a:t>
             </a:r>
           </a:p>
           <a:p>
-            <a:pPr marL="0" lvl="0" indent="0" defTabSz="914400" eaLnBrk="0" fontAlgn="base" hangingPunct="0">
+            <a:pPr marL="0" indent="0" defTabSz="914400" eaLnBrk="0" fontAlgn="base" hangingPunct="0">
               <a:lnSpc>
                 <a:spcPct val="90000"/>
               </a:lnSpc>
@@ -9835,44 +9852,7 @@
             </a:r>
             <a:r>
               <a:rPr lang="en-US" dirty="0"/>
-              <a:t>Uses professional role standards</a:t>
-            </a:r>
-          </a:p>
-          <a:p>
-            <a:pPr marL="0" lvl="0" indent="0" defTabSz="914400" eaLnBrk="0" fontAlgn="base" hangingPunct="0">
-              <a:lnSpc>
-                <a:spcPct val="90000"/>
-              </a:lnSpc>
-              <a:spcBef>
-                <a:spcPct val="0"/>
-              </a:spcBef>
-              <a:spcAft>
-                <a:spcPts val="600"/>
-              </a:spcAft>
-              <a:buClrTx/>
-              <a:buSzTx/>
-              <a:buFontTx/>
-              <a:buChar char="•"/>
-            </a:pPr>
-            <a:r>
-              <a:rPr lang="en-US" altLang="en-FI" dirty="0">
-                <a:solidFill>
-                  <a:srgbClr val="FFFFFF"/>
-                </a:solidFill>
-              </a:rPr>
-              <a:t> </a:t>
-            </a:r>
-            <a:r>
-              <a:rPr lang="en-US" dirty="0"/>
-              <a:t>Applies filters (location, salary, industry)</a:t>
-            </a:r>
-            <a:r>
-              <a:rPr lang="en-US" altLang="en-FI" dirty="0">
-                <a:solidFill>
-                  <a:srgbClr val="FFFFFF"/>
-                </a:solidFill>
-              </a:rPr>
-              <a:t> </a:t>
+              <a:t>Improve user experience</a:t>
             </a:r>
           </a:p>
           <a:p>
@@ -9888,8 +9868,7 @@
               </a:spcAft>
               <a:buClrTx/>
               <a:buSzTx/>
-              <a:buFontTx/>
-              <a:buChar char="•"/>
+              <a:buNone/>
               <a:tabLst/>
             </a:pPr>
             <a:endParaRPr lang="en-US" altLang="en-FI" dirty="0">

</xml_diff>